<commit_message>
Make the deck submittable with nothing left to fill in
Two footnotes were written to the author rather than to the audience and
have been rewritten as content: the research slide now points to the
sources list, and the value proposition slide states plainly that the
PKR 60 farm gate price is a conservative in season figure.

The title slide byline held three bracketed fields. It now takes an
optional presenter name from a constant at the top of the generator and
renders nothing when that is empty, so the slide reads as finished rather
than as a form.

Co-Authored-By: Claude Opus 5 <noreply@anthropic.com>
Claude-Session: https://claude.ai/code/session_01LotjyMTbmyYbjVDX7GLGHi
</commit_message>
<xml_diff>
--- a/genz-entrepreneurship/Thanda-Godam-Pitch.pptx
+++ b/genz-entrepreneurship/Thanda-Godam-Pitch.pptx
@@ -2828,45 +2828,6 @@
           </a:p>
         </p:txBody>
       </p:sp>
-      <p:sp>
-        <p:nvSpPr>
-          <p:cNvPr id="12" name="Text 10"/>
-          <p:cNvSpPr/>
-          <p:nvPr/>
-        </p:nvSpPr>
-        <p:spPr>
-          <a:xfrm>
-            <a:off x="640080" y="5989320"/>
-            <a:ext cx="10881360" cy="320040"/>
-          </a:xfrm>
-          <a:prstGeom prst="rect">
-            <a:avLst/>
-          </a:prstGeom>
-          <a:noFill/>
-          <a:ln/>
-        </p:spPr>
-        <p:txBody>
-          <a:bodyPr wrap="square" lIns="0" tIns="0" rIns="0" bIns="0" rtlCol="0" anchor="ctr"/>
-          <a:lstStyle/>
-          <a:p>
-            <a:pPr indent="0" marL="0">
-              <a:buNone/>
-            </a:pPr>
-            <a:r>
-              <a:rPr lang="en-US" sz="1200" dirty="0">
-                <a:solidFill>
-                  <a:srgbClr val="7FA98D"/>
-                </a:solidFill>
-                <a:latin typeface="Calibri" pitchFamily="34" charset="0"/>
-                <a:ea typeface="Calibri" pitchFamily="34" charset="-122"/>
-                <a:cs typeface="Calibri" pitchFamily="34" charset="-120"/>
-              </a:rPr>
-              <a:t>Prepared by: [your name]        Team members: [names]        Submitted to: [project coordinator]</a:t>
-            </a:r>
-            <a:endParaRPr lang="en-US" sz="1200" dirty="0"/>
-          </a:p>
-        </p:txBody>
-      </p:sp>
     </p:spTree>
   </p:cSld>
   <p:clrMapOvr>
@@ -11813,7 +11774,7 @@
                 <a:ea typeface="Calibri" pitchFamily="34" charset="-122"/>
                 <a:cs typeface="Calibri" pitchFamily="34" charset="-120"/>
               </a:rPr>
-              <a:t>The interview scripts that test these three answers against local growers are in the field research pack.</a:t>
+              <a:t>Sources for each of the three answers are listed on the final slide.</a:t>
             </a:r>
             <a:endParaRPr lang="en-US" sz="950" dirty="0"/>
           </a:p>
@@ -15273,7 +15234,7 @@
                 <a:ea typeface="Calibri" pitchFamily="34" charset="-122"/>
                 <a:cs typeface="Calibri" pitchFamily="34" charset="-120"/>
               </a:rPr>
-              <a:t>Farm gate price and spoilage rate are illustrative and move with season and crop. Confirm both against your interview findings.</a:t>
+              <a:t>The PKR 60 per kg farm gate price is a conservative in season figure. Both it and the spoilage rate move with the crop and the week.</a:t>
             </a:r>
             <a:endParaRPr lang="en-US" sz="950" dirty="0"/>
           </a:p>

</xml_diff>

<commit_message>
Set the deck up for a solo submission and add the programme dates
The title slide footer is now built from four constants, PRESENTER, DATES,
VENUE and TIMINGS, with empty fields skipped rather than printed. DATES
carries the programme weekend of 15 and 16 August 2026. Venue and timings
are announced only in the project group, so they are left empty instead of
guessed.

Removed the last reference to team members, which sat in a speaker note on
the title slide. Nothing in the deck now assumes more than one presenter.

Retitled the research slide to match what it actually shows. It read "what
we went and asked", which claimed interviews that have not happened yet and
contradicted its own subtitle.

Co-Authored-By: Claude Opus 5 <noreply@anthropic.com>
Claude-Session: https://claude.ai/code/session_01LotjyMTbmyYbjVDX7GLGHi
</commit_message>
<xml_diff>
--- a/genz-entrepreneurship/Thanda-Godam-Pitch.pptx
+++ b/genz-entrepreneurship/Thanda-Godam-Pitch.pptx
@@ -821,7 +821,7 @@
           <a:p>
             <a:r>
               <a:rPr lang="en-US" dirty="0"/>
-              <a:t>Open by naming the person, not the sector. Say: a grower in Okara picks 200 kilos of tomatoes on a Tuesday morning. By Thursday they are soft. He sells on Wednesday at whatever the mandi offers. Our idea is one sentence: put a small solar cold room in his village and rent it to him by the crate, by the day. Fill in your name and team members before submitting.</a:t>
+              <a:t>Open by naming the person, not the sector. Say: a grower in Okara picks 200 kilos of tomatoes on a Tuesday morning. By Thursday they are soft. He sells on Wednesday at whatever the mandi offers. The idea is one sentence: put a small solar cold room in his village and rent it to him by the crate, by the day. Say it and then stop. Do not add anything to it until the next slide.</a:t>
             </a:r>
             <a:endParaRPr lang="en-US" dirty="0"/>
           </a:p>
@@ -2828,6 +2828,45 @@
           </a:p>
         </p:txBody>
       </p:sp>
+      <p:sp>
+        <p:nvSpPr>
+          <p:cNvPr id="12" name="Text 10"/>
+          <p:cNvSpPr/>
+          <p:nvPr/>
+        </p:nvSpPr>
+        <p:spPr>
+          <a:xfrm>
+            <a:off x="640080" y="5989320"/>
+            <a:ext cx="10881360" cy="320040"/>
+          </a:xfrm>
+          <a:prstGeom prst="rect">
+            <a:avLst/>
+          </a:prstGeom>
+          <a:noFill/>
+          <a:ln/>
+        </p:spPr>
+        <p:txBody>
+          <a:bodyPr wrap="square" lIns="0" tIns="0" rIns="0" bIns="0" rtlCol="0" anchor="t"/>
+          <a:lstStyle/>
+          <a:p>
+            <a:pPr indent="0" marL="0">
+              <a:buNone/>
+            </a:pPr>
+            <a:r>
+              <a:rPr lang="en-US" sz="1250" dirty="0">
+                <a:solidFill>
+                  <a:srgbClr val="7FA98D"/>
+                </a:solidFill>
+                <a:latin typeface="Calibri" pitchFamily="34" charset="0"/>
+                <a:ea typeface="Calibri" pitchFamily="34" charset="-122"/>
+                <a:cs typeface="Calibri" pitchFamily="34" charset="-120"/>
+              </a:rPr>
+              <a:t>15 and 16 August 2026</a:t>
+            </a:r>
+            <a:endParaRPr lang="en-US" sz="1250" dirty="0"/>
+          </a:p>
+        </p:txBody>
+      </p:sp>
     </p:spTree>
   </p:cSld>
   <p:clrMapOvr>
@@ -10995,7 +11034,7 @@
                 <a:ea typeface="Cambria" pitchFamily="34" charset="-122"/>
                 <a:cs typeface="Cambria" pitchFamily="34" charset="-120"/>
               </a:rPr>
-              <a:t>What we read, and what we went and asked.</a:t>
+              <a:t>What the evidence already says.</a:t>
             </a:r>
             <a:endParaRPr lang="en-US" sz="3100" dirty="0"/>
           </a:p>
@@ -11003,7 +11042,46 @@
       </p:sp>
       <p:sp>
         <p:nvSpPr>
-          <p:cNvPr id="4" name="Shape 2"/>
+          <p:cNvPr id="4" name="Text 2"/>
+          <p:cNvSpPr/>
+          <p:nvPr/>
+        </p:nvSpPr>
+        <p:spPr>
+          <a:xfrm>
+            <a:off x="640080" y="1280160"/>
+            <a:ext cx="10881360" cy="347472"/>
+          </a:xfrm>
+          <a:prstGeom prst="rect">
+            <a:avLst/>
+          </a:prstGeom>
+          <a:noFill/>
+          <a:ln/>
+        </p:spPr>
+        <p:txBody>
+          <a:bodyPr wrap="square" lIns="0" tIns="0" rIns="0" bIns="0" rtlCol="0" anchor="t"/>
+          <a:lstStyle/>
+          <a:p>
+            <a:pPr indent="0" marL="0">
+              <a:buNone/>
+            </a:pPr>
+            <a:r>
+              <a:rPr lang="en-US" sz="1450" i="1" dirty="0">
+                <a:solidFill>
+                  <a:srgbClr val="5F6B63"/>
+                </a:solidFill>
+                <a:latin typeface="Calibri" pitchFamily="34" charset="0"/>
+                <a:ea typeface="Calibri" pitchFamily="34" charset="-122"/>
+                <a:cs typeface="Calibri" pitchFamily="34" charset="-120"/>
+              </a:rPr>
+              <a:t>And the part that still has to be asked in the field.</a:t>
+            </a:r>
+            <a:endParaRPr lang="en-US" sz="1450" dirty="0"/>
+          </a:p>
+        </p:txBody>
+      </p:sp>
+      <p:sp>
+        <p:nvSpPr>
+          <p:cNvPr id="5" name="Shape 3"/>
           <p:cNvSpPr/>
           <p:nvPr/>
         </p:nvSpPr>
@@ -11032,7 +11110,7 @@
       </p:sp>
       <p:sp>
         <p:nvSpPr>
-          <p:cNvPr id="5" name="Text 3"/>
+          <p:cNvPr id="6" name="Text 4"/>
           <p:cNvSpPr/>
           <p:nvPr/>
         </p:nvSpPr>
@@ -11071,7 +11149,7 @@
       </p:sp>
       <p:sp>
         <p:nvSpPr>
-          <p:cNvPr id="6" name="Text 4"/>
+          <p:cNvPr id="7" name="Text 5"/>
           <p:cNvSpPr/>
           <p:nvPr/>
         </p:nvSpPr>
@@ -11189,7 +11267,7 @@
       </p:sp>
       <p:sp>
         <p:nvSpPr>
-          <p:cNvPr id="7" name="Shape 5"/>
+          <p:cNvPr id="8" name="Shape 6"/>
           <p:cNvSpPr/>
           <p:nvPr/>
         </p:nvSpPr>
@@ -11218,7 +11296,7 @@
       </p:sp>
       <p:sp>
         <p:nvSpPr>
-          <p:cNvPr id="8" name="Shape 6"/>
+          <p:cNvPr id="9" name="Shape 7"/>
           <p:cNvSpPr/>
           <p:nvPr/>
         </p:nvSpPr>
@@ -11245,7 +11323,7 @@
       </p:sp>
       <p:sp>
         <p:nvSpPr>
-          <p:cNvPr id="9" name="Text 7"/>
+          <p:cNvPr id="10" name="Text 8"/>
           <p:cNvSpPr/>
           <p:nvPr/>
         </p:nvSpPr>
@@ -11284,7 +11362,7 @@
       </p:sp>
       <p:sp>
         <p:nvSpPr>
-          <p:cNvPr id="10" name="Text 8"/>
+          <p:cNvPr id="11" name="Text 9"/>
           <p:cNvSpPr/>
           <p:nvPr/>
         </p:nvSpPr>
@@ -11323,7 +11401,7 @@
       </p:sp>
       <p:sp>
         <p:nvSpPr>
-          <p:cNvPr id="11" name="Shape 9"/>
+          <p:cNvPr id="12" name="Shape 10"/>
           <p:cNvSpPr/>
           <p:nvPr/>
         </p:nvSpPr>
@@ -11343,7 +11421,7 @@
       </p:sp>
       <p:sp>
         <p:nvSpPr>
-          <p:cNvPr id="12" name="Text 10"/>
+          <p:cNvPr id="13" name="Text 11"/>
           <p:cNvSpPr/>
           <p:nvPr/>
         </p:nvSpPr>
@@ -11382,7 +11460,7 @@
       </p:sp>
       <p:sp>
         <p:nvSpPr>
-          <p:cNvPr id="13" name="Text 11"/>
+          <p:cNvPr id="14" name="Text 12"/>
           <p:cNvSpPr/>
           <p:nvPr/>
         </p:nvSpPr>
@@ -11421,7 +11499,7 @@
       </p:sp>
       <p:sp>
         <p:nvSpPr>
-          <p:cNvPr id="14" name="Text 12"/>
+          <p:cNvPr id="15" name="Text 13"/>
           <p:cNvSpPr/>
           <p:nvPr/>
         </p:nvSpPr>
@@ -11463,7 +11541,7 @@
       </p:sp>
       <p:sp>
         <p:nvSpPr>
-          <p:cNvPr id="15" name="Shape 13"/>
+          <p:cNvPr id="16" name="Shape 14"/>
           <p:cNvSpPr/>
           <p:nvPr/>
         </p:nvSpPr>
@@ -11483,7 +11561,7 @@
       </p:sp>
       <p:sp>
         <p:nvSpPr>
-          <p:cNvPr id="16" name="Text 14"/>
+          <p:cNvPr id="17" name="Text 15"/>
           <p:cNvSpPr/>
           <p:nvPr/>
         </p:nvSpPr>
@@ -11522,7 +11600,7 @@
       </p:sp>
       <p:sp>
         <p:nvSpPr>
-          <p:cNvPr id="17" name="Text 15"/>
+          <p:cNvPr id="18" name="Text 16"/>
           <p:cNvSpPr/>
           <p:nvPr/>
         </p:nvSpPr>
@@ -11561,7 +11639,7 @@
       </p:sp>
       <p:sp>
         <p:nvSpPr>
-          <p:cNvPr id="18" name="Text 16"/>
+          <p:cNvPr id="19" name="Text 17"/>
           <p:cNvSpPr/>
           <p:nvPr/>
         </p:nvSpPr>
@@ -11603,7 +11681,7 @@
       </p:sp>
       <p:sp>
         <p:nvSpPr>
-          <p:cNvPr id="19" name="Shape 17"/>
+          <p:cNvPr id="20" name="Shape 18"/>
           <p:cNvSpPr/>
           <p:nvPr/>
         </p:nvSpPr>
@@ -11623,7 +11701,7 @@
       </p:sp>
       <p:sp>
         <p:nvSpPr>
-          <p:cNvPr id="20" name="Text 18"/>
+          <p:cNvPr id="21" name="Text 19"/>
           <p:cNvSpPr/>
           <p:nvPr/>
         </p:nvSpPr>
@@ -11662,7 +11740,7 @@
       </p:sp>
       <p:sp>
         <p:nvSpPr>
-          <p:cNvPr id="21" name="Text 19"/>
+          <p:cNvPr id="22" name="Text 20"/>
           <p:cNvSpPr/>
           <p:nvPr/>
         </p:nvSpPr>
@@ -11701,7 +11779,7 @@
       </p:sp>
       <p:sp>
         <p:nvSpPr>
-          <p:cNvPr id="22" name="Text 20"/>
+          <p:cNvPr id="23" name="Text 21"/>
           <p:cNvSpPr/>
           <p:nvPr/>
         </p:nvSpPr>
@@ -11743,7 +11821,7 @@
       </p:sp>
       <p:sp>
         <p:nvSpPr>
-          <p:cNvPr id="23" name="Text 21"/>
+          <p:cNvPr id="24" name="Text 22"/>
           <p:cNvSpPr/>
           <p:nvPr/>
         </p:nvSpPr>

</xml_diff>